<commit_message>
update plots & spring cleaning
</commit_message>
<xml_diff>
--- a/plots/labelling.pptx
+++ b/plots/labelling.pptx
@@ -263,7 +263,7 @@
           <a:p>
             <a:fld id="{7D23C940-8F42-FE43-8415-281A589944F6}" type="datetimeFigureOut">
               <a:rPr lang="en-US" smtClean="0"/>
-              <a:t>8/14/25</a:t>
+              <a:t>10/17/25</a:t>
             </a:fld>
             <a:endParaRPr lang="en-US"/>
           </a:p>
@@ -463,7 +463,7 @@
           <a:p>
             <a:fld id="{7D23C940-8F42-FE43-8415-281A589944F6}" type="datetimeFigureOut">
               <a:rPr lang="en-US" smtClean="0"/>
-              <a:t>8/14/25</a:t>
+              <a:t>10/17/25</a:t>
             </a:fld>
             <a:endParaRPr lang="en-US"/>
           </a:p>
@@ -673,7 +673,7 @@
           <a:p>
             <a:fld id="{7D23C940-8F42-FE43-8415-281A589944F6}" type="datetimeFigureOut">
               <a:rPr lang="en-US" smtClean="0"/>
-              <a:t>8/14/25</a:t>
+              <a:t>10/17/25</a:t>
             </a:fld>
             <a:endParaRPr lang="en-US"/>
           </a:p>
@@ -873,7 +873,7 @@
           <a:p>
             <a:fld id="{7D23C940-8F42-FE43-8415-281A589944F6}" type="datetimeFigureOut">
               <a:rPr lang="en-US" smtClean="0"/>
-              <a:t>8/14/25</a:t>
+              <a:t>10/17/25</a:t>
             </a:fld>
             <a:endParaRPr lang="en-US"/>
           </a:p>
@@ -1149,7 +1149,7 @@
           <a:p>
             <a:fld id="{7D23C940-8F42-FE43-8415-281A589944F6}" type="datetimeFigureOut">
               <a:rPr lang="en-US" smtClean="0"/>
-              <a:t>8/14/25</a:t>
+              <a:t>10/17/25</a:t>
             </a:fld>
             <a:endParaRPr lang="en-US"/>
           </a:p>
@@ -1417,7 +1417,7 @@
           <a:p>
             <a:fld id="{7D23C940-8F42-FE43-8415-281A589944F6}" type="datetimeFigureOut">
               <a:rPr lang="en-US" smtClean="0"/>
-              <a:t>8/14/25</a:t>
+              <a:t>10/17/25</a:t>
             </a:fld>
             <a:endParaRPr lang="en-US"/>
           </a:p>
@@ -1832,7 +1832,7 @@
           <a:p>
             <a:fld id="{7D23C940-8F42-FE43-8415-281A589944F6}" type="datetimeFigureOut">
               <a:rPr lang="en-US" smtClean="0"/>
-              <a:t>8/14/25</a:t>
+              <a:t>10/17/25</a:t>
             </a:fld>
             <a:endParaRPr lang="en-US"/>
           </a:p>
@@ -1974,7 +1974,7 @@
           <a:p>
             <a:fld id="{7D23C940-8F42-FE43-8415-281A589944F6}" type="datetimeFigureOut">
               <a:rPr lang="en-US" smtClean="0"/>
-              <a:t>8/14/25</a:t>
+              <a:t>10/17/25</a:t>
             </a:fld>
             <a:endParaRPr lang="en-US"/>
           </a:p>
@@ -2087,7 +2087,7 @@
           <a:p>
             <a:fld id="{7D23C940-8F42-FE43-8415-281A589944F6}" type="datetimeFigureOut">
               <a:rPr lang="en-US" smtClean="0"/>
-              <a:t>8/14/25</a:t>
+              <a:t>10/17/25</a:t>
             </a:fld>
             <a:endParaRPr lang="en-US"/>
           </a:p>
@@ -2400,7 +2400,7 @@
           <a:p>
             <a:fld id="{7D23C940-8F42-FE43-8415-281A589944F6}" type="datetimeFigureOut">
               <a:rPr lang="en-US" smtClean="0"/>
-              <a:t>8/14/25</a:t>
+              <a:t>10/17/25</a:t>
             </a:fld>
             <a:endParaRPr lang="en-US"/>
           </a:p>
@@ -2689,7 +2689,7 @@
           <a:p>
             <a:fld id="{7D23C940-8F42-FE43-8415-281A589944F6}" type="datetimeFigureOut">
               <a:rPr lang="en-US" smtClean="0"/>
-              <a:t>8/14/25</a:t>
+              <a:t>10/17/25</a:t>
             </a:fld>
             <a:endParaRPr lang="en-US"/>
           </a:p>
@@ -2932,7 +2932,7 @@
           <a:p>
             <a:fld id="{7D23C940-8F42-FE43-8415-281A589944F6}" type="datetimeFigureOut">
               <a:rPr lang="en-US" smtClean="0"/>
-              <a:t>8/14/25</a:t>
+              <a:t>10/17/25</a:t>
             </a:fld>
             <a:endParaRPr lang="en-US"/>
           </a:p>
@@ -3984,10 +3984,10 @@
       </p:grpSpPr>
       <p:grpSp>
         <p:nvGrpSpPr>
-          <p:cNvPr id="36" name="Group 35">
-            <a:extLst>
-              <a:ext uri="{FF2B5EF4-FFF2-40B4-BE49-F238E27FC236}">
-                <a16:creationId xmlns:a16="http://schemas.microsoft.com/office/drawing/2014/main" id="{F0AD7695-315A-F393-83C9-19747BB9D52D}"/>
+          <p:cNvPr id="54" name="Group 53">
+            <a:extLst>
+              <a:ext uri="{FF2B5EF4-FFF2-40B4-BE49-F238E27FC236}">
+                <a16:creationId xmlns:a16="http://schemas.microsoft.com/office/drawing/2014/main" id="{89EE98A5-25B8-D1C7-E9DE-876D7DB8AF5E}"/>
               </a:ext>
             </a:extLst>
           </p:cNvPr>
@@ -3998,7 +3998,7 @@
           <a:xfrm>
             <a:off x="1281409" y="0"/>
             <a:ext cx="6858000" cy="6858000"/>
-            <a:chOff x="1249" y="0"/>
+            <a:chOff x="1281409" y="0"/>
             <a:chExt cx="6858000" cy="6858000"/>
           </a:xfrm>
         </p:grpSpPr>
@@ -4024,7 +4024,7 @@
           </p:blipFill>
           <p:spPr>
             <a:xfrm>
-              <a:off x="1249" y="0"/>
+              <a:off x="1281409" y="0"/>
               <a:ext cx="6858000" cy="6858000"/>
             </a:xfrm>
             <a:prstGeom prst="rect">
@@ -4046,8 +4046,8 @@
           </p:nvSpPr>
           <p:spPr>
             <a:xfrm>
-              <a:off x="2678569" y="1252516"/>
-              <a:ext cx="1503360" cy="276999"/>
+              <a:off x="4029931" y="1267829"/>
+              <a:ext cx="1394934" cy="261610"/>
             </a:xfrm>
             <a:prstGeom prst="rect">
               <a:avLst/>
@@ -4061,7 +4061,7 @@
             <a:lstStyle/>
             <a:p>
               <a:r>
-                <a:rPr lang="en-US" sz="1200" dirty="0">
+                <a:rPr lang="en-US" sz="1100" dirty="0">
                   <a:solidFill>
                     <a:srgbClr val="322288"/>
                   </a:solidFill>
@@ -4085,54 +4085,13 @@
           </p:nvCxnSpPr>
           <p:spPr>
             <a:xfrm>
-              <a:off x="2099861" y="494932"/>
+              <a:off x="3728606" y="451279"/>
               <a:ext cx="0" cy="1796565"/>
             </a:xfrm>
             <a:prstGeom prst="line">
               <a:avLst/>
             </a:prstGeom>
-            <a:ln>
-              <a:solidFill>
-                <a:srgbClr val="322288"/>
-              </a:solidFill>
-            </a:ln>
-          </p:spPr>
-          <p:style>
-            <a:lnRef idx="2">
-              <a:schemeClr val="accent1"/>
-            </a:lnRef>
-            <a:fillRef idx="0">
-              <a:schemeClr val="accent1"/>
-            </a:fillRef>
-            <a:effectRef idx="1">
-              <a:schemeClr val="accent1"/>
-            </a:effectRef>
-            <a:fontRef idx="minor">
-              <a:schemeClr val="tx1"/>
-            </a:fontRef>
-          </p:style>
-        </p:cxnSp>
-        <p:cxnSp>
-          <p:nvCxnSpPr>
-            <p:cNvPr id="7" name="Straight Connector 6">
-              <a:extLst>
-                <a:ext uri="{FF2B5EF4-FFF2-40B4-BE49-F238E27FC236}">
-                  <a16:creationId xmlns:a16="http://schemas.microsoft.com/office/drawing/2014/main" id="{F4B1DA19-6EA5-F450-07CB-678A25F3AA40}"/>
-                </a:ext>
-              </a:extLst>
-            </p:cNvPr>
-            <p:cNvCxnSpPr/>
-            <p:nvPr/>
-          </p:nvCxnSpPr>
-          <p:spPr>
-            <a:xfrm>
-              <a:off x="4794293" y="494932"/>
-              <a:ext cx="0" cy="1796565"/>
-            </a:xfrm>
-            <a:prstGeom prst="line">
-              <a:avLst/>
-            </a:prstGeom>
-            <a:ln>
+            <a:ln w="12700">
               <a:solidFill>
                 <a:srgbClr val="322288"/>
               </a:solidFill>
@@ -4167,8 +4126,8 @@
           </p:nvSpPr>
           <p:spPr>
             <a:xfrm>
-              <a:off x="2660134" y="2227672"/>
-              <a:ext cx="1540230" cy="276999"/>
+              <a:off x="4012298" y="2221531"/>
+              <a:ext cx="1430200" cy="261610"/>
             </a:xfrm>
             <a:prstGeom prst="rect">
               <a:avLst/>
@@ -4182,7 +4141,7 @@
             <a:lstStyle/>
             <a:p>
               <a:r>
-                <a:rPr lang="en-US" sz="1200" dirty="0">
+                <a:rPr lang="en-US" sz="1100" dirty="0">
                   <a:solidFill>
                     <a:srgbClr val="88CCEE"/>
                   </a:solidFill>
@@ -4206,8 +4165,8 @@
           </p:nvSpPr>
           <p:spPr>
             <a:xfrm>
-              <a:off x="3081549" y="2442213"/>
-              <a:ext cx="695511" cy="276999"/>
+              <a:off x="4401027" y="2410899"/>
+              <a:ext cx="652743" cy="261610"/>
             </a:xfrm>
             <a:prstGeom prst="rect">
               <a:avLst/>
@@ -4221,7 +4180,7 @@
             <a:lstStyle/>
             <a:p>
               <a:r>
-                <a:rPr lang="en-US" sz="1200" dirty="0">
+                <a:rPr lang="en-US" sz="1100" dirty="0">
                   <a:solidFill>
                     <a:srgbClr val="CBDDA6"/>
                   </a:solidFill>
@@ -4245,54 +4204,13 @@
           </p:nvCxnSpPr>
           <p:spPr>
             <a:xfrm>
-              <a:off x="2099861" y="2662168"/>
+              <a:off x="3731920" y="2662168"/>
               <a:ext cx="0" cy="524403"/>
             </a:xfrm>
             <a:prstGeom prst="line">
               <a:avLst/>
             </a:prstGeom>
-            <a:ln>
-              <a:solidFill>
-                <a:srgbClr val="44AA99"/>
-              </a:solidFill>
-            </a:ln>
-          </p:spPr>
-          <p:style>
-            <a:lnRef idx="2">
-              <a:schemeClr val="accent1"/>
-            </a:lnRef>
-            <a:fillRef idx="0">
-              <a:schemeClr val="accent1"/>
-            </a:fillRef>
-            <a:effectRef idx="1">
-              <a:schemeClr val="accent1"/>
-            </a:effectRef>
-            <a:fontRef idx="minor">
-              <a:schemeClr val="tx1"/>
-            </a:fontRef>
-          </p:style>
-        </p:cxnSp>
-        <p:cxnSp>
-          <p:nvCxnSpPr>
-            <p:cNvPr id="26" name="Straight Connector 25">
-              <a:extLst>
-                <a:ext uri="{FF2B5EF4-FFF2-40B4-BE49-F238E27FC236}">
-                  <a16:creationId xmlns:a16="http://schemas.microsoft.com/office/drawing/2014/main" id="{6E8BBC75-A91A-BAB0-AF50-F6AFD9004A36}"/>
-                </a:ext>
-              </a:extLst>
-            </p:cNvPr>
-            <p:cNvCxnSpPr/>
-            <p:nvPr/>
-          </p:nvCxnSpPr>
-          <p:spPr>
-            <a:xfrm>
-              <a:off x="4794293" y="2662168"/>
-              <a:ext cx="0" cy="524403"/>
-            </a:xfrm>
-            <a:prstGeom prst="line">
-              <a:avLst/>
-            </a:prstGeom>
-            <a:ln>
+            <a:ln w="12700">
               <a:solidFill>
                 <a:srgbClr val="44AA99"/>
               </a:solidFill>
@@ -4327,8 +4245,8 @@
           </p:nvSpPr>
           <p:spPr>
             <a:xfrm>
-              <a:off x="2920103" y="2795253"/>
-              <a:ext cx="1015534" cy="276999"/>
+              <a:off x="4257666" y="2792387"/>
+              <a:ext cx="946093" cy="261610"/>
             </a:xfrm>
             <a:prstGeom prst="rect">
               <a:avLst/>
@@ -4336,13 +4254,13 @@
             <a:noFill/>
           </p:spPr>
           <p:txBody>
-            <a:bodyPr wrap="none" rtlCol="0">
+            <a:bodyPr wrap="square" rtlCol="0">
               <a:spAutoFit/>
             </a:bodyPr>
             <a:lstStyle/>
             <a:p>
               <a:r>
-                <a:rPr lang="en-US" sz="1200" dirty="0">
+                <a:rPr lang="en-US" sz="1100" dirty="0">
                   <a:solidFill>
                     <a:srgbClr val="44AA99"/>
                   </a:solidFill>
@@ -4366,8 +4284,8 @@
           </p:nvSpPr>
           <p:spPr>
             <a:xfrm>
-              <a:off x="2920103" y="3224334"/>
-              <a:ext cx="1020344" cy="276999"/>
+              <a:off x="4254460" y="3304021"/>
+              <a:ext cx="949299" cy="261610"/>
             </a:xfrm>
             <a:prstGeom prst="rect">
               <a:avLst/>
@@ -4381,7 +4299,7 @@
             <a:lstStyle/>
             <a:p>
               <a:r>
-                <a:rPr lang="en-US" sz="1200" dirty="0">
+                <a:rPr lang="en-US" sz="1100" dirty="0">
                   <a:solidFill>
                     <a:srgbClr val="107733"/>
                   </a:solidFill>
@@ -4405,8 +4323,8 @@
           </p:nvSpPr>
           <p:spPr>
             <a:xfrm>
-              <a:off x="2920103" y="3618687"/>
-              <a:ext cx="1015534" cy="276999"/>
+              <a:off x="4247394" y="3613267"/>
+              <a:ext cx="946093" cy="261610"/>
             </a:xfrm>
             <a:prstGeom prst="rect">
               <a:avLst/>
@@ -4420,7 +4338,7 @@
             <a:lstStyle/>
             <a:p>
               <a:r>
-                <a:rPr lang="en-US" sz="1200" dirty="0">
+                <a:rPr lang="en-US" sz="1100" dirty="0">
                   <a:solidFill>
                     <a:srgbClr val="44AA99"/>
                   </a:solidFill>
@@ -4444,8 +4362,8 @@
           </p:nvSpPr>
           <p:spPr>
             <a:xfrm>
-              <a:off x="3108583" y="3982047"/>
-              <a:ext cx="638573" cy="276999"/>
+              <a:off x="4426931" y="3997358"/>
+              <a:ext cx="599844" cy="261610"/>
             </a:xfrm>
             <a:prstGeom prst="rect">
               <a:avLst/>
@@ -4459,7 +4377,7 @@
             <a:lstStyle/>
             <a:p>
               <a:r>
-                <a:rPr lang="en-US" sz="1200" dirty="0">
+                <a:rPr lang="en-US" sz="1100" dirty="0">
                   <a:solidFill>
                     <a:srgbClr val="DCCB73"/>
                   </a:solidFill>
@@ -4483,8 +4401,8 @@
           </p:nvSpPr>
           <p:spPr>
             <a:xfrm>
-              <a:off x="3096478" y="4364250"/>
-              <a:ext cx="688265" cy="276999"/>
+              <a:off x="4403687" y="4418565"/>
+              <a:ext cx="646331" cy="261610"/>
             </a:xfrm>
             <a:prstGeom prst="rect">
               <a:avLst/>
@@ -4498,7 +4416,7 @@
             <a:lstStyle/>
             <a:p>
               <a:r>
-                <a:rPr lang="en-US" sz="1200" dirty="0">
+                <a:rPr lang="en-US" sz="1100" dirty="0">
                   <a:solidFill>
                     <a:srgbClr val="999932"/>
                   </a:solidFill>
@@ -4522,8 +4440,8 @@
           </p:nvSpPr>
           <p:spPr>
             <a:xfrm>
-              <a:off x="3131456" y="4746454"/>
-              <a:ext cx="618311" cy="276999"/>
+              <a:off x="4436485" y="4743393"/>
+              <a:ext cx="587020" cy="261610"/>
             </a:xfrm>
             <a:prstGeom prst="rect">
               <a:avLst/>
@@ -4537,7 +4455,7 @@
             <a:lstStyle/>
             <a:p>
               <a:r>
-                <a:rPr lang="en-US" sz="1200" dirty="0">
+                <a:rPr lang="en-US" sz="1100" dirty="0">
                   <a:solidFill>
                     <a:srgbClr val="AA4399"/>
                   </a:solidFill>
@@ -4561,8 +4479,8 @@
           </p:nvSpPr>
           <p:spPr>
             <a:xfrm>
-              <a:off x="3015608" y="4989443"/>
-              <a:ext cx="824521" cy="276999"/>
+              <a:off x="4343511" y="4983213"/>
+              <a:ext cx="772969" cy="261610"/>
             </a:xfrm>
             <a:prstGeom prst="rect">
               <a:avLst/>
@@ -4576,7 +4494,7 @@
             <a:lstStyle/>
             <a:p>
               <a:r>
-                <a:rPr lang="en-US" sz="1200" dirty="0">
+                <a:rPr lang="en-US" sz="1100" dirty="0">
                   <a:solidFill>
                     <a:srgbClr val="CC6577"/>
                   </a:solidFill>
@@ -4600,8 +4518,8 @@
           </p:nvSpPr>
           <p:spPr>
             <a:xfrm>
-              <a:off x="2878326" y="5160028"/>
-              <a:ext cx="1099083" cy="276999"/>
+              <a:off x="4254460" y="5213530"/>
+              <a:ext cx="1026243" cy="261610"/>
             </a:xfrm>
             <a:prstGeom prst="rect">
               <a:avLst/>
@@ -4615,7 +4533,7 @@
             <a:lstStyle/>
             <a:p>
               <a:r>
-                <a:rPr lang="en-US" sz="1200" dirty="0">
+                <a:rPr lang="en-US" sz="1100" dirty="0">
                   <a:solidFill>
                     <a:srgbClr val="882155"/>
                   </a:solidFill>
@@ -4639,8 +4557,8 @@
           </p:nvSpPr>
           <p:spPr>
             <a:xfrm>
-              <a:off x="3015608" y="5442797"/>
-              <a:ext cx="898003" cy="261610"/>
+              <a:off x="4456289" y="5374676"/>
+              <a:ext cx="577402" cy="184666"/>
             </a:xfrm>
             <a:prstGeom prst="rect">
               <a:avLst/>
@@ -4654,12 +4572,868 @@
             <a:lstStyle/>
             <a:p>
               <a:r>
-                <a:rPr lang="en-US" sz="1100" dirty="0"/>
+                <a:rPr lang="en-US" sz="600" dirty="0"/>
                 <a:t>NC_031988</a:t>
               </a:r>
             </a:p>
           </p:txBody>
         </p:sp>
+        <p:cxnSp>
+          <p:nvCxnSpPr>
+            <p:cNvPr id="2" name="Straight Connector 1">
+              <a:extLst>
+                <a:ext uri="{FF2B5EF4-FFF2-40B4-BE49-F238E27FC236}">
+                  <a16:creationId xmlns:a16="http://schemas.microsoft.com/office/drawing/2014/main" id="{8C8E67DC-7201-3CC7-FA98-961E91F27E5E}"/>
+                </a:ext>
+              </a:extLst>
+            </p:cNvPr>
+            <p:cNvCxnSpPr>
+              <a:cxnSpLocks/>
+            </p:cNvCxnSpPr>
+            <p:nvPr/>
+          </p:nvCxnSpPr>
+          <p:spPr>
+            <a:xfrm>
+              <a:off x="3731203" y="5266442"/>
+              <a:ext cx="0" cy="155787"/>
+            </a:xfrm>
+            <a:prstGeom prst="line">
+              <a:avLst/>
+            </a:prstGeom>
+            <a:ln w="12700">
+              <a:solidFill>
+                <a:srgbClr val="882155"/>
+              </a:solidFill>
+            </a:ln>
+          </p:spPr>
+          <p:style>
+            <a:lnRef idx="2">
+              <a:schemeClr val="accent1"/>
+            </a:lnRef>
+            <a:fillRef idx="0">
+              <a:schemeClr val="accent1"/>
+            </a:fillRef>
+            <a:effectRef idx="1">
+              <a:schemeClr val="accent1"/>
+            </a:effectRef>
+            <a:fontRef idx="minor">
+              <a:schemeClr val="tx1"/>
+            </a:fontRef>
+          </p:style>
+        </p:cxnSp>
+        <p:cxnSp>
+          <p:nvCxnSpPr>
+            <p:cNvPr id="8" name="Straight Connector 7">
+              <a:extLst>
+                <a:ext uri="{FF2B5EF4-FFF2-40B4-BE49-F238E27FC236}">
+                  <a16:creationId xmlns:a16="http://schemas.microsoft.com/office/drawing/2014/main" id="{0ED68633-5449-0867-11A6-61453BA4C1F7}"/>
+                </a:ext>
+              </a:extLst>
+            </p:cNvPr>
+            <p:cNvCxnSpPr>
+              <a:cxnSpLocks/>
+            </p:cNvCxnSpPr>
+            <p:nvPr/>
+          </p:nvCxnSpPr>
+          <p:spPr>
+            <a:xfrm>
+              <a:off x="3731203" y="4989443"/>
+              <a:ext cx="0" cy="237244"/>
+            </a:xfrm>
+            <a:prstGeom prst="line">
+              <a:avLst/>
+            </a:prstGeom>
+            <a:ln w="12700">
+              <a:solidFill>
+                <a:srgbClr val="CC6577"/>
+              </a:solidFill>
+            </a:ln>
+          </p:spPr>
+          <p:style>
+            <a:lnRef idx="2">
+              <a:schemeClr val="accent1"/>
+            </a:lnRef>
+            <a:fillRef idx="0">
+              <a:schemeClr val="accent1"/>
+            </a:fillRef>
+            <a:effectRef idx="1">
+              <a:schemeClr val="accent1"/>
+            </a:effectRef>
+            <a:fontRef idx="minor">
+              <a:schemeClr val="tx1"/>
+            </a:fontRef>
+          </p:style>
+        </p:cxnSp>
+        <p:cxnSp>
+          <p:nvCxnSpPr>
+            <p:cNvPr id="10" name="Straight Connector 9">
+              <a:extLst>
+                <a:ext uri="{FF2B5EF4-FFF2-40B4-BE49-F238E27FC236}">
+                  <a16:creationId xmlns:a16="http://schemas.microsoft.com/office/drawing/2014/main" id="{F44798C3-585E-5026-7D3A-7684193EA10C}"/>
+                </a:ext>
+              </a:extLst>
+            </p:cNvPr>
+            <p:cNvCxnSpPr>
+              <a:cxnSpLocks/>
+            </p:cNvCxnSpPr>
+            <p:nvPr/>
+          </p:nvCxnSpPr>
+          <p:spPr>
+            <a:xfrm>
+              <a:off x="3731203" y="4746454"/>
+              <a:ext cx="0" cy="210737"/>
+            </a:xfrm>
+            <a:prstGeom prst="line">
+              <a:avLst/>
+            </a:prstGeom>
+            <a:ln w="12700">
+              <a:solidFill>
+                <a:srgbClr val="AA4399"/>
+              </a:solidFill>
+            </a:ln>
+          </p:spPr>
+          <p:style>
+            <a:lnRef idx="2">
+              <a:schemeClr val="accent1"/>
+            </a:lnRef>
+            <a:fillRef idx="0">
+              <a:schemeClr val="accent1"/>
+            </a:fillRef>
+            <a:effectRef idx="1">
+              <a:schemeClr val="accent1"/>
+            </a:effectRef>
+            <a:fontRef idx="minor">
+              <a:schemeClr val="tx1"/>
+            </a:fontRef>
+          </p:style>
+        </p:cxnSp>
+        <p:cxnSp>
+          <p:nvCxnSpPr>
+            <p:cNvPr id="14" name="Straight Connector 13">
+              <a:extLst>
+                <a:ext uri="{FF2B5EF4-FFF2-40B4-BE49-F238E27FC236}">
+                  <a16:creationId xmlns:a16="http://schemas.microsoft.com/office/drawing/2014/main" id="{2B68A228-1E53-1FCD-6475-D49E47D47911}"/>
+                </a:ext>
+              </a:extLst>
+            </p:cNvPr>
+            <p:cNvCxnSpPr>
+              <a:cxnSpLocks/>
+            </p:cNvCxnSpPr>
+            <p:nvPr/>
+          </p:nvCxnSpPr>
+          <p:spPr>
+            <a:xfrm>
+              <a:off x="3731203" y="4397072"/>
+              <a:ext cx="0" cy="312642"/>
+            </a:xfrm>
+            <a:prstGeom prst="line">
+              <a:avLst/>
+            </a:prstGeom>
+            <a:ln w="12700">
+              <a:solidFill>
+                <a:srgbClr val="999932"/>
+              </a:solidFill>
+            </a:ln>
+          </p:spPr>
+          <p:style>
+            <a:lnRef idx="2">
+              <a:schemeClr val="accent1"/>
+            </a:lnRef>
+            <a:fillRef idx="0">
+              <a:schemeClr val="accent1"/>
+            </a:fillRef>
+            <a:effectRef idx="1">
+              <a:schemeClr val="accent1"/>
+            </a:effectRef>
+            <a:fontRef idx="minor">
+              <a:schemeClr val="tx1"/>
+            </a:fontRef>
+          </p:style>
+        </p:cxnSp>
+        <p:cxnSp>
+          <p:nvCxnSpPr>
+            <p:cNvPr id="16" name="Straight Connector 15">
+              <a:extLst>
+                <a:ext uri="{FF2B5EF4-FFF2-40B4-BE49-F238E27FC236}">
+                  <a16:creationId xmlns:a16="http://schemas.microsoft.com/office/drawing/2014/main" id="{57A7B235-D711-DE7F-6D9D-E3FAC2ACE451}"/>
+                </a:ext>
+              </a:extLst>
+            </p:cNvPr>
+            <p:cNvCxnSpPr>
+              <a:cxnSpLocks/>
+            </p:cNvCxnSpPr>
+            <p:nvPr/>
+          </p:nvCxnSpPr>
+          <p:spPr>
+            <a:xfrm>
+              <a:off x="3731203" y="3895686"/>
+              <a:ext cx="0" cy="468564"/>
+            </a:xfrm>
+            <a:prstGeom prst="line">
+              <a:avLst/>
+            </a:prstGeom>
+            <a:ln w="12700">
+              <a:solidFill>
+                <a:srgbClr val="DCCB73"/>
+              </a:solidFill>
+            </a:ln>
+          </p:spPr>
+          <p:style>
+            <a:lnRef idx="2">
+              <a:schemeClr val="accent1"/>
+            </a:lnRef>
+            <a:fillRef idx="0">
+              <a:schemeClr val="accent1"/>
+            </a:fillRef>
+            <a:effectRef idx="1">
+              <a:schemeClr val="accent1"/>
+            </a:effectRef>
+            <a:fontRef idx="minor">
+              <a:schemeClr val="tx1"/>
+            </a:fontRef>
+          </p:style>
+        </p:cxnSp>
+        <p:cxnSp>
+          <p:nvCxnSpPr>
+            <p:cNvPr id="21" name="Straight Connector 20">
+              <a:extLst>
+                <a:ext uri="{FF2B5EF4-FFF2-40B4-BE49-F238E27FC236}">
+                  <a16:creationId xmlns:a16="http://schemas.microsoft.com/office/drawing/2014/main" id="{E300A4F7-39D7-470F-E129-8495AB7CEBA2}"/>
+                </a:ext>
+              </a:extLst>
+            </p:cNvPr>
+            <p:cNvCxnSpPr>
+              <a:cxnSpLocks/>
+            </p:cNvCxnSpPr>
+            <p:nvPr/>
+          </p:nvCxnSpPr>
+          <p:spPr>
+            <a:xfrm>
+              <a:off x="3731203" y="3614628"/>
+              <a:ext cx="0" cy="266260"/>
+            </a:xfrm>
+            <a:prstGeom prst="line">
+              <a:avLst/>
+            </a:prstGeom>
+            <a:ln w="12700">
+              <a:solidFill>
+                <a:srgbClr val="44AA99"/>
+              </a:solidFill>
+            </a:ln>
+          </p:spPr>
+          <p:style>
+            <a:lnRef idx="2">
+              <a:schemeClr val="accent1"/>
+            </a:lnRef>
+            <a:fillRef idx="0">
+              <a:schemeClr val="accent1"/>
+            </a:fillRef>
+            <a:effectRef idx="1">
+              <a:schemeClr val="accent1"/>
+            </a:effectRef>
+            <a:fontRef idx="minor">
+              <a:schemeClr val="tx1"/>
+            </a:fontRef>
+          </p:style>
+        </p:cxnSp>
+        <p:cxnSp>
+          <p:nvCxnSpPr>
+            <p:cNvPr id="24" name="Straight Connector 23">
+              <a:extLst>
+                <a:ext uri="{FF2B5EF4-FFF2-40B4-BE49-F238E27FC236}">
+                  <a16:creationId xmlns:a16="http://schemas.microsoft.com/office/drawing/2014/main" id="{618925AB-0056-456E-ABE3-EE4FDF01A811}"/>
+                </a:ext>
+              </a:extLst>
+            </p:cNvPr>
+            <p:cNvCxnSpPr>
+              <a:cxnSpLocks/>
+            </p:cNvCxnSpPr>
+            <p:nvPr/>
+          </p:nvCxnSpPr>
+          <p:spPr>
+            <a:xfrm>
+              <a:off x="3731203" y="3216383"/>
+              <a:ext cx="0" cy="382343"/>
+            </a:xfrm>
+            <a:prstGeom prst="line">
+              <a:avLst/>
+            </a:prstGeom>
+            <a:ln w="12700">
+              <a:solidFill>
+                <a:srgbClr val="107733"/>
+              </a:solidFill>
+            </a:ln>
+          </p:spPr>
+          <p:style>
+            <a:lnRef idx="2">
+              <a:schemeClr val="accent1"/>
+            </a:lnRef>
+            <a:fillRef idx="0">
+              <a:schemeClr val="accent1"/>
+            </a:fillRef>
+            <a:effectRef idx="1">
+              <a:schemeClr val="accent1"/>
+            </a:effectRef>
+            <a:fontRef idx="minor">
+              <a:schemeClr val="tx1"/>
+            </a:fontRef>
+          </p:style>
+        </p:cxnSp>
+        <p:cxnSp>
+          <p:nvCxnSpPr>
+            <p:cNvPr id="39" name="Straight Connector 38">
+              <a:extLst>
+                <a:ext uri="{FF2B5EF4-FFF2-40B4-BE49-F238E27FC236}">
+                  <a16:creationId xmlns:a16="http://schemas.microsoft.com/office/drawing/2014/main" id="{4C85A3C4-80AC-5772-DF76-0828EC5F621F}"/>
+                </a:ext>
+              </a:extLst>
+            </p:cNvPr>
+            <p:cNvCxnSpPr>
+              <a:cxnSpLocks/>
+            </p:cNvCxnSpPr>
+            <p:nvPr/>
+          </p:nvCxnSpPr>
+          <p:spPr>
+            <a:xfrm>
+              <a:off x="3731203" y="2442213"/>
+              <a:ext cx="0" cy="195588"/>
+            </a:xfrm>
+            <a:prstGeom prst="line">
+              <a:avLst/>
+            </a:prstGeom>
+            <a:ln w="12700">
+              <a:solidFill>
+                <a:srgbClr val="CBDDA6"/>
+              </a:solidFill>
+            </a:ln>
+          </p:spPr>
+          <p:style>
+            <a:lnRef idx="2">
+              <a:schemeClr val="accent1"/>
+            </a:lnRef>
+            <a:fillRef idx="0">
+              <a:schemeClr val="accent1"/>
+            </a:fillRef>
+            <a:effectRef idx="1">
+              <a:schemeClr val="accent1"/>
+            </a:effectRef>
+            <a:fontRef idx="minor">
+              <a:schemeClr val="tx1"/>
+            </a:fontRef>
+          </p:style>
+        </p:cxnSp>
+        <p:cxnSp>
+          <p:nvCxnSpPr>
+            <p:cNvPr id="41" name="Straight Connector 40">
+              <a:extLst>
+                <a:ext uri="{FF2B5EF4-FFF2-40B4-BE49-F238E27FC236}">
+                  <a16:creationId xmlns:a16="http://schemas.microsoft.com/office/drawing/2014/main" id="{85416659-305F-2799-13D5-F3B9EFC92105}"/>
+                </a:ext>
+              </a:extLst>
+            </p:cNvPr>
+            <p:cNvCxnSpPr>
+              <a:cxnSpLocks/>
+            </p:cNvCxnSpPr>
+            <p:nvPr/>
+          </p:nvCxnSpPr>
+          <p:spPr>
+            <a:xfrm flipH="1">
+              <a:off x="3728606" y="2291497"/>
+              <a:ext cx="2597" cy="131763"/>
+            </a:xfrm>
+            <a:prstGeom prst="line">
+              <a:avLst/>
+            </a:prstGeom>
+            <a:ln w="12700">
+              <a:solidFill>
+                <a:srgbClr val="88CCEE"/>
+              </a:solidFill>
+            </a:ln>
+          </p:spPr>
+          <p:style>
+            <a:lnRef idx="2">
+              <a:schemeClr val="accent1"/>
+            </a:lnRef>
+            <a:fillRef idx="0">
+              <a:schemeClr val="accent1"/>
+            </a:fillRef>
+            <a:effectRef idx="1">
+              <a:schemeClr val="accent1"/>
+            </a:effectRef>
+            <a:fontRef idx="minor">
+              <a:schemeClr val="tx1"/>
+            </a:fontRef>
+          </p:style>
+        </p:cxnSp>
+        <p:cxnSp>
+          <p:nvCxnSpPr>
+            <p:cNvPr id="43" name="Straight Connector 42">
+              <a:extLst>
+                <a:ext uri="{FF2B5EF4-FFF2-40B4-BE49-F238E27FC236}">
+                  <a16:creationId xmlns:a16="http://schemas.microsoft.com/office/drawing/2014/main" id="{314A160A-E452-191A-1450-E8325FA66A09}"/>
+                </a:ext>
+              </a:extLst>
+            </p:cNvPr>
+            <p:cNvCxnSpPr/>
+            <p:nvPr/>
+          </p:nvCxnSpPr>
+          <p:spPr>
+            <a:xfrm>
+              <a:off x="5726190" y="451279"/>
+              <a:ext cx="0" cy="1796565"/>
+            </a:xfrm>
+            <a:prstGeom prst="line">
+              <a:avLst/>
+            </a:prstGeom>
+            <a:ln w="12700">
+              <a:solidFill>
+                <a:srgbClr val="322288"/>
+              </a:solidFill>
+            </a:ln>
+          </p:spPr>
+          <p:style>
+            <a:lnRef idx="2">
+              <a:schemeClr val="accent1"/>
+            </a:lnRef>
+            <a:fillRef idx="0">
+              <a:schemeClr val="accent1"/>
+            </a:fillRef>
+            <a:effectRef idx="1">
+              <a:schemeClr val="accent1"/>
+            </a:effectRef>
+            <a:fontRef idx="minor">
+              <a:schemeClr val="tx1"/>
+            </a:fontRef>
+          </p:style>
+        </p:cxnSp>
+        <p:cxnSp>
+          <p:nvCxnSpPr>
+            <p:cNvPr id="44" name="Straight Connector 43">
+              <a:extLst>
+                <a:ext uri="{FF2B5EF4-FFF2-40B4-BE49-F238E27FC236}">
+                  <a16:creationId xmlns:a16="http://schemas.microsoft.com/office/drawing/2014/main" id="{96356EDA-7CE9-E353-70BD-293CA595EDF0}"/>
+                </a:ext>
+              </a:extLst>
+            </p:cNvPr>
+            <p:cNvCxnSpPr/>
+            <p:nvPr/>
+          </p:nvCxnSpPr>
+          <p:spPr>
+            <a:xfrm>
+              <a:off x="5729504" y="2662168"/>
+              <a:ext cx="0" cy="524403"/>
+            </a:xfrm>
+            <a:prstGeom prst="line">
+              <a:avLst/>
+            </a:prstGeom>
+            <a:ln w="12700">
+              <a:solidFill>
+                <a:srgbClr val="44AA99"/>
+              </a:solidFill>
+            </a:ln>
+          </p:spPr>
+          <p:style>
+            <a:lnRef idx="2">
+              <a:schemeClr val="accent1"/>
+            </a:lnRef>
+            <a:fillRef idx="0">
+              <a:schemeClr val="accent1"/>
+            </a:fillRef>
+            <a:effectRef idx="1">
+              <a:schemeClr val="accent1"/>
+            </a:effectRef>
+            <a:fontRef idx="minor">
+              <a:schemeClr val="tx1"/>
+            </a:fontRef>
+          </p:style>
+        </p:cxnSp>
+        <p:cxnSp>
+          <p:nvCxnSpPr>
+            <p:cNvPr id="45" name="Straight Connector 44">
+              <a:extLst>
+                <a:ext uri="{FF2B5EF4-FFF2-40B4-BE49-F238E27FC236}">
+                  <a16:creationId xmlns:a16="http://schemas.microsoft.com/office/drawing/2014/main" id="{573FD269-596B-698A-A3D0-C1D7945EB267}"/>
+                </a:ext>
+              </a:extLst>
+            </p:cNvPr>
+            <p:cNvCxnSpPr>
+              <a:cxnSpLocks/>
+            </p:cNvCxnSpPr>
+            <p:nvPr/>
+          </p:nvCxnSpPr>
+          <p:spPr>
+            <a:xfrm>
+              <a:off x="5728787" y="5266442"/>
+              <a:ext cx="0" cy="155787"/>
+            </a:xfrm>
+            <a:prstGeom prst="line">
+              <a:avLst/>
+            </a:prstGeom>
+            <a:ln w="12700">
+              <a:solidFill>
+                <a:srgbClr val="882155"/>
+              </a:solidFill>
+            </a:ln>
+          </p:spPr>
+          <p:style>
+            <a:lnRef idx="2">
+              <a:schemeClr val="accent1"/>
+            </a:lnRef>
+            <a:fillRef idx="0">
+              <a:schemeClr val="accent1"/>
+            </a:fillRef>
+            <a:effectRef idx="1">
+              <a:schemeClr val="accent1"/>
+            </a:effectRef>
+            <a:fontRef idx="minor">
+              <a:schemeClr val="tx1"/>
+            </a:fontRef>
+          </p:style>
+        </p:cxnSp>
+        <p:cxnSp>
+          <p:nvCxnSpPr>
+            <p:cNvPr id="46" name="Straight Connector 45">
+              <a:extLst>
+                <a:ext uri="{FF2B5EF4-FFF2-40B4-BE49-F238E27FC236}">
+                  <a16:creationId xmlns:a16="http://schemas.microsoft.com/office/drawing/2014/main" id="{F1357C6D-28A0-42A2-7369-2D3E7B532CC4}"/>
+                </a:ext>
+              </a:extLst>
+            </p:cNvPr>
+            <p:cNvCxnSpPr>
+              <a:cxnSpLocks/>
+            </p:cNvCxnSpPr>
+            <p:nvPr/>
+          </p:nvCxnSpPr>
+          <p:spPr>
+            <a:xfrm>
+              <a:off x="5728787" y="4989443"/>
+              <a:ext cx="0" cy="237244"/>
+            </a:xfrm>
+            <a:prstGeom prst="line">
+              <a:avLst/>
+            </a:prstGeom>
+            <a:ln w="12700">
+              <a:solidFill>
+                <a:srgbClr val="CC6577"/>
+              </a:solidFill>
+            </a:ln>
+          </p:spPr>
+          <p:style>
+            <a:lnRef idx="2">
+              <a:schemeClr val="accent1"/>
+            </a:lnRef>
+            <a:fillRef idx="0">
+              <a:schemeClr val="accent1"/>
+            </a:fillRef>
+            <a:effectRef idx="1">
+              <a:schemeClr val="accent1"/>
+            </a:effectRef>
+            <a:fontRef idx="minor">
+              <a:schemeClr val="tx1"/>
+            </a:fontRef>
+          </p:style>
+        </p:cxnSp>
+        <p:cxnSp>
+          <p:nvCxnSpPr>
+            <p:cNvPr id="47" name="Straight Connector 46">
+              <a:extLst>
+                <a:ext uri="{FF2B5EF4-FFF2-40B4-BE49-F238E27FC236}">
+                  <a16:creationId xmlns:a16="http://schemas.microsoft.com/office/drawing/2014/main" id="{21696706-4B59-3292-BA07-36F41CC73342}"/>
+                </a:ext>
+              </a:extLst>
+            </p:cNvPr>
+            <p:cNvCxnSpPr>
+              <a:cxnSpLocks/>
+            </p:cNvCxnSpPr>
+            <p:nvPr/>
+          </p:nvCxnSpPr>
+          <p:spPr>
+            <a:xfrm>
+              <a:off x="5728787" y="4746454"/>
+              <a:ext cx="0" cy="210737"/>
+            </a:xfrm>
+            <a:prstGeom prst="line">
+              <a:avLst/>
+            </a:prstGeom>
+            <a:ln w="12700">
+              <a:solidFill>
+                <a:srgbClr val="AA4399"/>
+              </a:solidFill>
+            </a:ln>
+          </p:spPr>
+          <p:style>
+            <a:lnRef idx="2">
+              <a:schemeClr val="accent1"/>
+            </a:lnRef>
+            <a:fillRef idx="0">
+              <a:schemeClr val="accent1"/>
+            </a:fillRef>
+            <a:effectRef idx="1">
+              <a:schemeClr val="accent1"/>
+            </a:effectRef>
+            <a:fontRef idx="minor">
+              <a:schemeClr val="tx1"/>
+            </a:fontRef>
+          </p:style>
+        </p:cxnSp>
+        <p:cxnSp>
+          <p:nvCxnSpPr>
+            <p:cNvPr id="48" name="Straight Connector 47">
+              <a:extLst>
+                <a:ext uri="{FF2B5EF4-FFF2-40B4-BE49-F238E27FC236}">
+                  <a16:creationId xmlns:a16="http://schemas.microsoft.com/office/drawing/2014/main" id="{0605BBA2-9FB8-2738-DDD5-2F0C55C62B39}"/>
+                </a:ext>
+              </a:extLst>
+            </p:cNvPr>
+            <p:cNvCxnSpPr>
+              <a:cxnSpLocks/>
+            </p:cNvCxnSpPr>
+            <p:nvPr/>
+          </p:nvCxnSpPr>
+          <p:spPr>
+            <a:xfrm>
+              <a:off x="5728787" y="4397072"/>
+              <a:ext cx="0" cy="312642"/>
+            </a:xfrm>
+            <a:prstGeom prst="line">
+              <a:avLst/>
+            </a:prstGeom>
+            <a:ln w="12700">
+              <a:solidFill>
+                <a:srgbClr val="999932"/>
+              </a:solidFill>
+            </a:ln>
+          </p:spPr>
+          <p:style>
+            <a:lnRef idx="2">
+              <a:schemeClr val="accent1"/>
+            </a:lnRef>
+            <a:fillRef idx="0">
+              <a:schemeClr val="accent1"/>
+            </a:fillRef>
+            <a:effectRef idx="1">
+              <a:schemeClr val="accent1"/>
+            </a:effectRef>
+            <a:fontRef idx="minor">
+              <a:schemeClr val="tx1"/>
+            </a:fontRef>
+          </p:style>
+        </p:cxnSp>
+        <p:cxnSp>
+          <p:nvCxnSpPr>
+            <p:cNvPr id="49" name="Straight Connector 48">
+              <a:extLst>
+                <a:ext uri="{FF2B5EF4-FFF2-40B4-BE49-F238E27FC236}">
+                  <a16:creationId xmlns:a16="http://schemas.microsoft.com/office/drawing/2014/main" id="{3518746F-3B8E-DE54-1106-59EEE1B126AC}"/>
+                </a:ext>
+              </a:extLst>
+            </p:cNvPr>
+            <p:cNvCxnSpPr>
+              <a:cxnSpLocks/>
+            </p:cNvCxnSpPr>
+            <p:nvPr/>
+          </p:nvCxnSpPr>
+          <p:spPr>
+            <a:xfrm>
+              <a:off x="5728787" y="3895686"/>
+              <a:ext cx="0" cy="468564"/>
+            </a:xfrm>
+            <a:prstGeom prst="line">
+              <a:avLst/>
+            </a:prstGeom>
+            <a:ln w="12700">
+              <a:solidFill>
+                <a:srgbClr val="DCCB73"/>
+              </a:solidFill>
+            </a:ln>
+          </p:spPr>
+          <p:style>
+            <a:lnRef idx="2">
+              <a:schemeClr val="accent1"/>
+            </a:lnRef>
+            <a:fillRef idx="0">
+              <a:schemeClr val="accent1"/>
+            </a:fillRef>
+            <a:effectRef idx="1">
+              <a:schemeClr val="accent1"/>
+            </a:effectRef>
+            <a:fontRef idx="minor">
+              <a:schemeClr val="tx1"/>
+            </a:fontRef>
+          </p:style>
+        </p:cxnSp>
+        <p:cxnSp>
+          <p:nvCxnSpPr>
+            <p:cNvPr id="50" name="Straight Connector 49">
+              <a:extLst>
+                <a:ext uri="{FF2B5EF4-FFF2-40B4-BE49-F238E27FC236}">
+                  <a16:creationId xmlns:a16="http://schemas.microsoft.com/office/drawing/2014/main" id="{A0427A4D-BA4A-D9E2-AADD-CB86CC0F33E1}"/>
+                </a:ext>
+              </a:extLst>
+            </p:cNvPr>
+            <p:cNvCxnSpPr>
+              <a:cxnSpLocks/>
+            </p:cNvCxnSpPr>
+            <p:nvPr/>
+          </p:nvCxnSpPr>
+          <p:spPr>
+            <a:xfrm>
+              <a:off x="5728787" y="3614628"/>
+              <a:ext cx="0" cy="266260"/>
+            </a:xfrm>
+            <a:prstGeom prst="line">
+              <a:avLst/>
+            </a:prstGeom>
+            <a:ln w="12700">
+              <a:solidFill>
+                <a:srgbClr val="44AA99"/>
+              </a:solidFill>
+            </a:ln>
+          </p:spPr>
+          <p:style>
+            <a:lnRef idx="2">
+              <a:schemeClr val="accent1"/>
+            </a:lnRef>
+            <a:fillRef idx="0">
+              <a:schemeClr val="accent1"/>
+            </a:fillRef>
+            <a:effectRef idx="1">
+              <a:schemeClr val="accent1"/>
+            </a:effectRef>
+            <a:fontRef idx="minor">
+              <a:schemeClr val="tx1"/>
+            </a:fontRef>
+          </p:style>
+        </p:cxnSp>
+        <p:cxnSp>
+          <p:nvCxnSpPr>
+            <p:cNvPr id="51" name="Straight Connector 50">
+              <a:extLst>
+                <a:ext uri="{FF2B5EF4-FFF2-40B4-BE49-F238E27FC236}">
+                  <a16:creationId xmlns:a16="http://schemas.microsoft.com/office/drawing/2014/main" id="{10E69B08-5097-B434-75BD-43E38CF06840}"/>
+                </a:ext>
+              </a:extLst>
+            </p:cNvPr>
+            <p:cNvCxnSpPr>
+              <a:cxnSpLocks/>
+            </p:cNvCxnSpPr>
+            <p:nvPr/>
+          </p:nvCxnSpPr>
+          <p:spPr>
+            <a:xfrm>
+              <a:off x="5728787" y="3216383"/>
+              <a:ext cx="0" cy="382343"/>
+            </a:xfrm>
+            <a:prstGeom prst="line">
+              <a:avLst/>
+            </a:prstGeom>
+            <a:ln w="12700">
+              <a:solidFill>
+                <a:srgbClr val="107733"/>
+              </a:solidFill>
+            </a:ln>
+          </p:spPr>
+          <p:style>
+            <a:lnRef idx="2">
+              <a:schemeClr val="accent1"/>
+            </a:lnRef>
+            <a:fillRef idx="0">
+              <a:schemeClr val="accent1"/>
+            </a:fillRef>
+            <a:effectRef idx="1">
+              <a:schemeClr val="accent1"/>
+            </a:effectRef>
+            <a:fontRef idx="minor">
+              <a:schemeClr val="tx1"/>
+            </a:fontRef>
+          </p:style>
+        </p:cxnSp>
+        <p:cxnSp>
+          <p:nvCxnSpPr>
+            <p:cNvPr id="52" name="Straight Connector 51">
+              <a:extLst>
+                <a:ext uri="{FF2B5EF4-FFF2-40B4-BE49-F238E27FC236}">
+                  <a16:creationId xmlns:a16="http://schemas.microsoft.com/office/drawing/2014/main" id="{A23474CA-A723-17C2-CF8D-298D9618B28C}"/>
+                </a:ext>
+              </a:extLst>
+            </p:cNvPr>
+            <p:cNvCxnSpPr>
+              <a:cxnSpLocks/>
+            </p:cNvCxnSpPr>
+            <p:nvPr/>
+          </p:nvCxnSpPr>
+          <p:spPr>
+            <a:xfrm>
+              <a:off x="5728787" y="2442213"/>
+              <a:ext cx="0" cy="195588"/>
+            </a:xfrm>
+            <a:prstGeom prst="line">
+              <a:avLst/>
+            </a:prstGeom>
+            <a:ln w="12700">
+              <a:solidFill>
+                <a:srgbClr val="CBDDA6"/>
+              </a:solidFill>
+            </a:ln>
+          </p:spPr>
+          <p:style>
+            <a:lnRef idx="2">
+              <a:schemeClr val="accent1"/>
+            </a:lnRef>
+            <a:fillRef idx="0">
+              <a:schemeClr val="accent1"/>
+            </a:fillRef>
+            <a:effectRef idx="1">
+              <a:schemeClr val="accent1"/>
+            </a:effectRef>
+            <a:fontRef idx="minor">
+              <a:schemeClr val="tx1"/>
+            </a:fontRef>
+          </p:style>
+        </p:cxnSp>
+        <p:cxnSp>
+          <p:nvCxnSpPr>
+            <p:cNvPr id="53" name="Straight Connector 52">
+              <a:extLst>
+                <a:ext uri="{FF2B5EF4-FFF2-40B4-BE49-F238E27FC236}">
+                  <a16:creationId xmlns:a16="http://schemas.microsoft.com/office/drawing/2014/main" id="{E2E16764-A116-47D2-F5F8-AAE8ABCBEB92}"/>
+                </a:ext>
+              </a:extLst>
+            </p:cNvPr>
+            <p:cNvCxnSpPr>
+              <a:cxnSpLocks/>
+            </p:cNvCxnSpPr>
+            <p:nvPr/>
+          </p:nvCxnSpPr>
+          <p:spPr>
+            <a:xfrm flipH="1">
+              <a:off x="5726190" y="2291497"/>
+              <a:ext cx="2597" cy="131763"/>
+            </a:xfrm>
+            <a:prstGeom prst="line">
+              <a:avLst/>
+            </a:prstGeom>
+            <a:ln w="12700">
+              <a:solidFill>
+                <a:srgbClr val="88CCEE"/>
+              </a:solidFill>
+            </a:ln>
+          </p:spPr>
+          <p:style>
+            <a:lnRef idx="2">
+              <a:schemeClr val="accent1"/>
+            </a:lnRef>
+            <a:fillRef idx="0">
+              <a:schemeClr val="accent1"/>
+            </a:fillRef>
+            <a:effectRef idx="1">
+              <a:schemeClr val="accent1"/>
+            </a:effectRef>
+            <a:fontRef idx="minor">
+              <a:schemeClr val="tx1"/>
+            </a:fontRef>
+          </p:style>
+        </p:cxnSp>
       </p:grpSp>
     </p:spTree>
     <p:extLst>

</xml_diff>